<commit_message>
update ic, math in hvps
</commit_message>
<xml_diff>
--- a/hvps/architecture/originalDocuments/pepII supply.pptx
+++ b/hvps/architecture/originalDocuments/pepII supply.pptx
@@ -2486,7 +2486,7 @@
             <a:fld id="{37D864F4-F1EF-4C1C-86E7-760DE26223FA}" type="datetime1">
               <a:rPr lang="en-US" altLang="en-US"/>
               <a:pPr/>
-              <a:t>12/3/2024</a:t>
+              <a:t>3/13/2026</a:t>
             </a:fld>
             <a:endParaRPr lang="en-US" altLang="en-US"/>
           </a:p>
@@ -2719,7 +2719,7 @@
             <a:fld id="{7E9725D1-6DC7-408C-B961-0821111D2FF8}" type="datetime1">
               <a:rPr lang="en-US" altLang="en-US"/>
               <a:pPr/>
-              <a:t>12/3/2024</a:t>
+              <a:t>3/13/2026</a:t>
             </a:fld>
             <a:endParaRPr lang="en-US" altLang="en-US"/>
           </a:p>
@@ -2914,7 +2914,7 @@
             <a:fld id="{D08B4765-29EA-47FA-B542-92A9CCA07C68}" type="datetime1">
               <a:rPr lang="en-US" altLang="en-US"/>
               <a:pPr/>
-              <a:t>12/3/2024</a:t>
+              <a:t>3/13/2026</a:t>
             </a:fld>
             <a:endParaRPr lang="en-US" altLang="en-US"/>
           </a:p>
@@ -3226,7 +3226,7 @@
             <a:fld id="{EE6DF5DF-78F7-4C84-9451-CAA3259BB532}" type="datetime1">
               <a:rPr lang="en-US" altLang="en-US"/>
               <a:pPr/>
-              <a:t>12/3/2024</a:t>
+              <a:t>3/13/2026</a:t>
             </a:fld>
             <a:endParaRPr lang="en-US" altLang="en-US"/>
           </a:p>
@@ -3421,7 +3421,7 @@
             <a:fld id="{8973DF55-D4CA-4A0C-9A5E-214F6E32B689}" type="datetime1">
               <a:rPr lang="en-US" altLang="en-US"/>
               <a:pPr/>
-              <a:t>12/3/2024</a:t>
+              <a:t>3/13/2026</a:t>
             </a:fld>
             <a:endParaRPr lang="en-US" altLang="en-US"/>
           </a:p>
@@ -3629,7 +3629,7 @@
             <a:fld id="{2DB2D177-2C66-4972-B395-F0E4FE7F43C4}" type="datetime1">
               <a:rPr lang="en-US" altLang="en-US"/>
               <a:pPr/>
-              <a:t>12/3/2024</a:t>
+              <a:t>3/13/2026</a:t>
             </a:fld>
             <a:endParaRPr lang="en-US" altLang="en-US"/>
           </a:p>
@@ -3875,7 +3875,7 @@
             <a:fld id="{FB78574A-73CB-43A0-9D84-3F9DE8013851}" type="datetime1">
               <a:rPr lang="en-US" altLang="en-US"/>
               <a:pPr/>
-              <a:t>12/3/2024</a:t>
+              <a:t>3/13/2026</a:t>
             </a:fld>
             <a:endParaRPr lang="en-US" altLang="en-US"/>
           </a:p>
@@ -4256,7 +4256,7 @@
             <a:fld id="{45157649-8C4A-4050-8B90-F1706AE028DE}" type="datetime1">
               <a:rPr lang="en-US" altLang="en-US"/>
               <a:pPr/>
-              <a:t>12/3/2024</a:t>
+              <a:t>3/13/2026</a:t>
             </a:fld>
             <a:endParaRPr lang="en-US" altLang="en-US"/>
           </a:p>
@@ -4390,7 +4390,7 @@
             <a:fld id="{0A25A491-3A93-4D53-A6F0-24FD7DFC127E}" type="datetime1">
               <a:rPr lang="en-US" altLang="en-US"/>
               <a:pPr/>
-              <a:t>12/3/2024</a:t>
+              <a:t>3/13/2026</a:t>
             </a:fld>
             <a:endParaRPr lang="en-US" altLang="en-US"/>
           </a:p>
@@ -4502,7 +4502,7 @@
             <a:fld id="{4B8D9480-8DB7-4EB5-A697-B89779DF21E5}" type="datetime1">
               <a:rPr lang="en-US" altLang="en-US"/>
               <a:pPr/>
-              <a:t>12/3/2024</a:t>
+              <a:t>3/13/2026</a:t>
             </a:fld>
             <a:endParaRPr lang="en-US" altLang="en-US"/>
           </a:p>
@@ -4794,7 +4794,7 @@
             <a:fld id="{43636641-891B-4C1A-A125-5AEA232BFB23}" type="datetime1">
               <a:rPr lang="en-US" altLang="en-US"/>
               <a:pPr/>
-              <a:t>12/3/2024</a:t>
+              <a:t>3/13/2026</a:t>
             </a:fld>
             <a:endParaRPr lang="en-US" altLang="en-US"/>
           </a:p>
@@ -5063,7 +5063,7 @@
             <a:fld id="{9945A46E-D5D4-4C55-9315-79A024B9AE5D}" type="datetime1">
               <a:rPr lang="en-US" altLang="en-US"/>
               <a:pPr/>
-              <a:t>12/3/2024</a:t>
+              <a:t>3/13/2026</a:t>
             </a:fld>
             <a:endParaRPr lang="en-US" altLang="en-US"/>
           </a:p>
@@ -5392,7 +5392,7 @@
             <a:fld id="{53FF3FD2-EBE3-466E-AF34-C15BC15C264B}" type="datetime1">
               <a:rPr lang="en-US" altLang="en-US"/>
               <a:pPr/>
-              <a:t>12/3/2024</a:t>
+              <a:t>3/13/2026</a:t>
             </a:fld>
             <a:endParaRPr lang="en-US" altLang="en-US"/>
           </a:p>
@@ -6045,7 +6045,7 @@
             <a:fld id="{0CFC4C81-99AB-4948-966C-E3F17CAD5D9E}" type="datetime1">
               <a:rPr lang="en-US" altLang="en-US"/>
               <a:pPr/>
-              <a:t>12/3/2024</a:t>
+              <a:t>3/13/2026</a:t>
             </a:fld>
             <a:endParaRPr lang="en-US" altLang="en-US"/>
           </a:p>
@@ -6295,7 +6295,7 @@
             <a:fld id="{27290404-B4DF-40C6-BC44-F975D45F3652}" type="datetime1">
               <a:rPr lang="en-US" altLang="en-US"/>
               <a:pPr/>
-              <a:t>12/3/2024</a:t>
+              <a:t>3/13/2026</a:t>
             </a:fld>
             <a:endParaRPr lang="en-US" altLang="en-US"/>
           </a:p>
@@ -6501,7 +6501,7 @@
             <a:fld id="{719C60F9-E9A0-4E94-B5FA-11FE3BFD834F}" type="datetime1">
               <a:rPr lang="en-US" altLang="en-US"/>
               <a:pPr/>
-              <a:t>12/3/2024</a:t>
+              <a:t>3/13/2026</a:t>
             </a:fld>
             <a:endParaRPr lang="en-US" altLang="en-US"/>
           </a:p>
@@ -6868,7 +6868,7 @@
             <a:fld id="{124285A3-C37C-49F6-9502-FE6FBE380AB5}" type="datetime1">
               <a:rPr lang="en-US" altLang="en-US"/>
               <a:pPr/>
-              <a:t>12/3/2024</a:t>
+              <a:t>3/13/2026</a:t>
             </a:fld>
             <a:endParaRPr lang="en-US" altLang="en-US"/>
           </a:p>
@@ -7081,7 +7081,7 @@
             <a:fld id="{5664618A-4497-40BA-840C-643D9404D01A}" type="datetime1">
               <a:rPr lang="en-US" altLang="en-US"/>
               <a:pPr/>
-              <a:t>12/3/2024</a:t>
+              <a:t>3/13/2026</a:t>
             </a:fld>
             <a:endParaRPr lang="en-US" altLang="en-US"/>
           </a:p>
@@ -7295,7 +7295,7 @@
             <a:fld id="{7F204474-FE4F-4EC5-8598-1F33B22D8CAE}" type="datetime1">
               <a:rPr lang="en-US" altLang="en-US"/>
               <a:pPr/>
-              <a:t>12/3/2024</a:t>
+              <a:t>3/13/2026</a:t>
             </a:fld>
             <a:endParaRPr lang="en-US" altLang="en-US"/>
           </a:p>
@@ -7509,7 +7509,7 @@
             <a:fld id="{898A632C-3411-4773-807C-F25A21C96E07}" type="datetime1">
               <a:rPr lang="en-US" altLang="en-US"/>
               <a:pPr/>
-              <a:t>12/3/2024</a:t>
+              <a:t>3/13/2026</a:t>
             </a:fld>
             <a:endParaRPr lang="en-US" altLang="en-US"/>
           </a:p>
@@ -7749,7 +7749,7 @@
             <a:fld id="{31F42ACC-04CE-4688-85CF-7DCA9BC02C80}" type="datetime1">
               <a:rPr lang="en-US" altLang="en-US"/>
               <a:pPr/>
-              <a:t>12/3/2024</a:t>
+              <a:t>3/13/2026</a:t>
             </a:fld>
             <a:endParaRPr lang="en-US" altLang="en-US"/>
           </a:p>
@@ -8064,7 +8064,7 @@
             <a:fld id="{B62C2B18-D8B0-4327-AAD6-763896B9AB90}" type="datetime1">
               <a:rPr lang="en-US" altLang="en-US"/>
               <a:pPr/>
-              <a:t>12/3/2024</a:t>
+              <a:t>3/13/2026</a:t>
             </a:fld>
             <a:endParaRPr lang="en-US" altLang="en-US"/>
           </a:p>
@@ -8391,7 +8391,7 @@
             <a:fld id="{7EF3C794-C5DF-4436-8782-C7B846B06FAE}" type="datetime1">
               <a:rPr lang="en-US" altLang="en-US"/>
               <a:pPr/>
-              <a:t>12/3/2024</a:t>
+              <a:t>3/13/2026</a:t>
             </a:fld>
             <a:endParaRPr lang="en-US" altLang="en-US"/>
           </a:p>
@@ -8617,7 +8617,7 @@
             <a:fld id="{A5F37007-08C2-4AFE-89A8-33328AF01C45}" type="datetime1">
               <a:rPr lang="en-US" altLang="en-US"/>
               <a:pPr/>
-              <a:t>12/3/2024</a:t>
+              <a:t>3/13/2026</a:t>
             </a:fld>
             <a:endParaRPr lang="en-US" altLang="en-US"/>
           </a:p>
@@ -8843,7 +8843,7 @@
             <a:fld id="{CDE7BFBB-67D8-487C-8BAB-AF09902A7461}" type="datetime1">
               <a:rPr lang="en-US" altLang="en-US"/>
               <a:pPr/>
-              <a:t>12/3/2024</a:t>
+              <a:t>3/13/2026</a:t>
             </a:fld>
             <a:endParaRPr lang="en-US" altLang="en-US"/>
           </a:p>
@@ -9006,7 +9006,7 @@
             <a:fld id="{EFEE55C9-48EA-44AC-BB42-A930FAB67FF7}" type="datetime1">
               <a:rPr lang="en-US" altLang="en-US"/>
               <a:pPr/>
-              <a:t>12/3/2024</a:t>
+              <a:t>3/13/2026</a:t>
             </a:fld>
             <a:endParaRPr lang="en-US" altLang="en-US"/>
           </a:p>
@@ -9232,7 +9232,7 @@
             <a:fld id="{95AD568F-B972-4F67-85AF-04AD77F18632}" type="datetime1">
               <a:rPr lang="en-US" altLang="en-US"/>
               <a:pPr/>
-              <a:t>12/3/2024</a:t>
+              <a:t>3/13/2026</a:t>
             </a:fld>
             <a:endParaRPr lang="en-US" altLang="en-US"/>
           </a:p>
@@ -9458,7 +9458,7 @@
             <a:fld id="{64164768-FE20-41BD-ABA5-598D55BAC4E8}" type="datetime1">
               <a:rPr lang="en-US" altLang="en-US"/>
               <a:pPr/>
-              <a:t>12/3/2024</a:t>
+              <a:t>3/13/2026</a:t>
             </a:fld>
             <a:endParaRPr lang="en-US" altLang="en-US"/>
           </a:p>
@@ -9684,7 +9684,7 @@
             <a:fld id="{DB353C4F-B573-4355-ADE8-B26D7B211FAE}" type="datetime1">
               <a:rPr lang="en-US" altLang="en-US"/>
               <a:pPr/>
-              <a:t>12/3/2024</a:t>
+              <a:t>3/13/2026</a:t>
             </a:fld>
             <a:endParaRPr lang="en-US" altLang="en-US"/>
           </a:p>
@@ -9910,7 +9910,7 @@
             <a:fld id="{9D5E5186-04E8-4985-8F89-3D0E4855441B}" type="datetime1">
               <a:rPr lang="en-US" altLang="en-US"/>
               <a:pPr/>
-              <a:t>12/3/2024</a:t>
+              <a:t>3/13/2026</a:t>
             </a:fld>
             <a:endParaRPr lang="en-US" altLang="en-US"/>
           </a:p>
@@ -10144,7 +10144,7 @@
             <a:fld id="{2E39DA36-FA9A-41F6-8987-1359E9BD18F3}" type="datetime1">
               <a:rPr lang="en-US" altLang="en-US"/>
               <a:pPr/>
-              <a:t>12/3/2024</a:t>
+              <a:t>3/13/2026</a:t>
             </a:fld>
             <a:endParaRPr lang="en-US" altLang="en-US"/>
           </a:p>
@@ -10360,7 +10360,7 @@
             <a:fld id="{6F39FBB0-CC1F-4EBF-8128-E84FABC6BCB8}" type="datetime1">
               <a:rPr lang="en-US" altLang="en-US"/>
               <a:pPr/>
-              <a:t>12/3/2024</a:t>
+              <a:t>3/13/2026</a:t>
             </a:fld>
             <a:endParaRPr lang="en-US" altLang="en-US"/>
           </a:p>
@@ -10614,7 +10614,7 @@
             <a:fld id="{5AE3DD3E-CD5B-4AE3-A197-85F8191312C3}" type="datetime1">
               <a:rPr lang="en-US" altLang="en-US"/>
               <a:pPr/>
-              <a:t>12/3/2024</a:t>
+              <a:t>3/13/2026</a:t>
             </a:fld>
             <a:endParaRPr lang="en-US" altLang="en-US"/>
           </a:p>
@@ -10800,7 +10800,7 @@
             <a:fld id="{35FC0B1C-157C-4459-9BE3-E39188D7EACD}" type="datetime1">
               <a:rPr lang="en-US" altLang="en-US"/>
               <a:pPr/>
-              <a:t>12/3/2024</a:t>
+              <a:t>3/13/2026</a:t>
             </a:fld>
             <a:endParaRPr lang="en-US" altLang="en-US"/>
           </a:p>
@@ -11014,7 +11014,7 @@
             <a:fld id="{98A19279-2967-450F-BDAD-47B5810551B9}" type="datetime1">
               <a:rPr lang="en-US" altLang="en-US"/>
               <a:pPr/>
-              <a:t>12/3/2024</a:t>
+              <a:t>3/13/2026</a:t>
             </a:fld>
             <a:endParaRPr lang="en-US" altLang="en-US"/>
           </a:p>
@@ -11200,7 +11200,7 @@
             <a:fld id="{33AB958A-789E-40C0-8B26-51D4E1BD65A6}" type="datetime1">
               <a:rPr lang="en-US" altLang="en-US"/>
               <a:pPr/>
-              <a:t>12/3/2024</a:t>
+              <a:t>3/13/2026</a:t>
             </a:fld>
             <a:endParaRPr lang="en-US" altLang="en-US"/>
           </a:p>
@@ -11406,7 +11406,7 @@
             <a:fld id="{4DD586B8-BE97-400C-A0C1-DCB36840D631}" type="datetime1">
               <a:rPr lang="en-US" altLang="en-US"/>
               <a:pPr/>
-              <a:t>12/3/2024</a:t>
+              <a:t>3/13/2026</a:t>
             </a:fld>
             <a:endParaRPr lang="en-US" altLang="en-US"/>
           </a:p>

</xml_diff>

<commit_message>
add doc_I, more images and updated doc_L
</commit_message>
<xml_diff>
--- a/hvps/architecture/originalDocuments/pepII supply.pptx
+++ b/hvps/architecture/originalDocuments/pepII supply.pptx
@@ -196,6 +196,43 @@
 </p:presentation>
 </file>
 
+<file path=ppt/revisionInfo.xml><?xml version="1.0" encoding="utf-8"?>
+<p1510:revInfo xmlns:a="http://schemas.openxmlformats.org/drawingml/2006/main" xmlns:r="http://schemas.openxmlformats.org/officeDocument/2006/relationships" xmlns:p1510="http://schemas.microsoft.com/office/powerpoint/2015/10/main">
+  <p1510:revLst>
+    <p1510:client id="{187FEA37-D950-4EBE-B4F2-A5AF6AF1BA4C}" v="1" dt="2026-04-07T19:23:01.107"/>
+  </p1510:revLst>
+</p1510:revInfo>
+</file>
+
+<file path=ppt/changesInfos/changesInfo1.xml><?xml version="1.0" encoding="utf-8"?>
+<pc:chgInfo xmlns:a="http://schemas.openxmlformats.org/drawingml/2006/main" xmlns:r="http://schemas.openxmlformats.org/officeDocument/2006/relationships" xmlns:ac="http://schemas.microsoft.com/office/drawing/2013/main/command" xmlns:pc="http://schemas.microsoft.com/office/powerpoint/2013/main/command">
+  <pc:docChgLst>
+    <pc:chgData name="Wang, Faya" userId="4e29d18d-b833-4cc8-a414-884259148607" providerId="ADAL" clId="{5EB190AF-59CA-4785-AE4E-41CA77A452D6}"/>
+    <pc:docChg chg="modSld">
+      <pc:chgData name="Wang, Faya" userId="4e29d18d-b833-4cc8-a414-884259148607" providerId="ADAL" clId="{5EB190AF-59CA-4785-AE4E-41CA77A452D6}" dt="2026-04-07T19:23:01.106" v="2" actId="5736"/>
+      <pc:docMkLst>
+        <pc:docMk/>
+      </pc:docMkLst>
+      <pc:sldChg chg="modSp mod">
+        <pc:chgData name="Wang, Faya" userId="4e29d18d-b833-4cc8-a414-884259148607" providerId="ADAL" clId="{5EB190AF-59CA-4785-AE4E-41CA77A452D6}" dt="2026-04-07T19:23:01.106" v="2" actId="5736"/>
+        <pc:sldMkLst>
+          <pc:docMk/>
+          <pc:sldMk cId="0" sldId="314"/>
+        </pc:sldMkLst>
+        <pc:graphicFrameChg chg="mod">
+          <ac:chgData name="Wang, Faya" userId="4e29d18d-b833-4cc8-a414-884259148607" providerId="ADAL" clId="{5EB190AF-59CA-4785-AE4E-41CA77A452D6}" dt="2026-04-07T19:23:01.106" v="2" actId="5736"/>
+          <ac:graphicFrameMkLst>
+            <pc:docMk/>
+            <pc:sldMk cId="0" sldId="314"/>
+            <ac:graphicFrameMk id="213002" creationId="{00000000-0000-0000-0000-000000000000}"/>
+          </ac:graphicFrameMkLst>
+        </pc:graphicFrameChg>
+      </pc:sldChg>
+    </pc:docChg>
+  </pc:docChgLst>
+</pc:chgInfo>
+</file>
+
 <file path=ppt/handoutMasters/handoutMaster1.xml><?xml version="1.0" encoding="utf-8"?>
 <p:handoutMaster xmlns:a="http://schemas.openxmlformats.org/drawingml/2006/main" xmlns:r="http://schemas.openxmlformats.org/officeDocument/2006/relationships" xmlns:p="http://schemas.openxmlformats.org/presentationml/2006/main">
   <p:cSld>
@@ -2486,7 +2523,7 @@
             <a:fld id="{37D864F4-F1EF-4C1C-86E7-760DE26223FA}" type="datetime1">
               <a:rPr lang="en-US" altLang="en-US"/>
               <a:pPr/>
-              <a:t>12/3/2024</a:t>
+              <a:t>4/7/2026</a:t>
             </a:fld>
             <a:endParaRPr lang="en-US" altLang="en-US"/>
           </a:p>
@@ -2719,7 +2756,7 @@
             <a:fld id="{7E9725D1-6DC7-408C-B961-0821111D2FF8}" type="datetime1">
               <a:rPr lang="en-US" altLang="en-US"/>
               <a:pPr/>
-              <a:t>12/3/2024</a:t>
+              <a:t>4/7/2026</a:t>
             </a:fld>
             <a:endParaRPr lang="en-US" altLang="en-US"/>
           </a:p>
@@ -2914,7 +2951,7 @@
             <a:fld id="{D08B4765-29EA-47FA-B542-92A9CCA07C68}" type="datetime1">
               <a:rPr lang="en-US" altLang="en-US"/>
               <a:pPr/>
-              <a:t>12/3/2024</a:t>
+              <a:t>4/7/2026</a:t>
             </a:fld>
             <a:endParaRPr lang="en-US" altLang="en-US"/>
           </a:p>
@@ -3226,7 +3263,7 @@
             <a:fld id="{EE6DF5DF-78F7-4C84-9451-CAA3259BB532}" type="datetime1">
               <a:rPr lang="en-US" altLang="en-US"/>
               <a:pPr/>
-              <a:t>12/3/2024</a:t>
+              <a:t>4/7/2026</a:t>
             </a:fld>
             <a:endParaRPr lang="en-US" altLang="en-US"/>
           </a:p>
@@ -3421,7 +3458,7 @@
             <a:fld id="{8973DF55-D4CA-4A0C-9A5E-214F6E32B689}" type="datetime1">
               <a:rPr lang="en-US" altLang="en-US"/>
               <a:pPr/>
-              <a:t>12/3/2024</a:t>
+              <a:t>4/7/2026</a:t>
             </a:fld>
             <a:endParaRPr lang="en-US" altLang="en-US"/>
           </a:p>
@@ -3629,7 +3666,7 @@
             <a:fld id="{2DB2D177-2C66-4972-B395-F0E4FE7F43C4}" type="datetime1">
               <a:rPr lang="en-US" altLang="en-US"/>
               <a:pPr/>
-              <a:t>12/3/2024</a:t>
+              <a:t>4/7/2026</a:t>
             </a:fld>
             <a:endParaRPr lang="en-US" altLang="en-US"/>
           </a:p>
@@ -3875,7 +3912,7 @@
             <a:fld id="{FB78574A-73CB-43A0-9D84-3F9DE8013851}" type="datetime1">
               <a:rPr lang="en-US" altLang="en-US"/>
               <a:pPr/>
-              <a:t>12/3/2024</a:t>
+              <a:t>4/7/2026</a:t>
             </a:fld>
             <a:endParaRPr lang="en-US" altLang="en-US"/>
           </a:p>
@@ -4256,7 +4293,7 @@
             <a:fld id="{45157649-8C4A-4050-8B90-F1706AE028DE}" type="datetime1">
               <a:rPr lang="en-US" altLang="en-US"/>
               <a:pPr/>
-              <a:t>12/3/2024</a:t>
+              <a:t>4/7/2026</a:t>
             </a:fld>
             <a:endParaRPr lang="en-US" altLang="en-US"/>
           </a:p>
@@ -4390,7 +4427,7 @@
             <a:fld id="{0A25A491-3A93-4D53-A6F0-24FD7DFC127E}" type="datetime1">
               <a:rPr lang="en-US" altLang="en-US"/>
               <a:pPr/>
-              <a:t>12/3/2024</a:t>
+              <a:t>4/7/2026</a:t>
             </a:fld>
             <a:endParaRPr lang="en-US" altLang="en-US"/>
           </a:p>
@@ -4502,7 +4539,7 @@
             <a:fld id="{4B8D9480-8DB7-4EB5-A697-B89779DF21E5}" type="datetime1">
               <a:rPr lang="en-US" altLang="en-US"/>
               <a:pPr/>
-              <a:t>12/3/2024</a:t>
+              <a:t>4/7/2026</a:t>
             </a:fld>
             <a:endParaRPr lang="en-US" altLang="en-US"/>
           </a:p>
@@ -4794,7 +4831,7 @@
             <a:fld id="{43636641-891B-4C1A-A125-5AEA232BFB23}" type="datetime1">
               <a:rPr lang="en-US" altLang="en-US"/>
               <a:pPr/>
-              <a:t>12/3/2024</a:t>
+              <a:t>4/7/2026</a:t>
             </a:fld>
             <a:endParaRPr lang="en-US" altLang="en-US"/>
           </a:p>
@@ -5063,7 +5100,7 @@
             <a:fld id="{9945A46E-D5D4-4C55-9315-79A024B9AE5D}" type="datetime1">
               <a:rPr lang="en-US" altLang="en-US"/>
               <a:pPr/>
-              <a:t>12/3/2024</a:t>
+              <a:t>4/7/2026</a:t>
             </a:fld>
             <a:endParaRPr lang="en-US" altLang="en-US"/>
           </a:p>
@@ -5392,7 +5429,7 @@
             <a:fld id="{53FF3FD2-EBE3-466E-AF34-C15BC15C264B}" type="datetime1">
               <a:rPr lang="en-US" altLang="en-US"/>
               <a:pPr/>
-              <a:t>12/3/2024</a:t>
+              <a:t>4/7/2026</a:t>
             </a:fld>
             <a:endParaRPr lang="en-US" altLang="en-US"/>
           </a:p>
@@ -6045,7 +6082,7 @@
             <a:fld id="{0CFC4C81-99AB-4948-966C-E3F17CAD5D9E}" type="datetime1">
               <a:rPr lang="en-US" altLang="en-US"/>
               <a:pPr/>
-              <a:t>12/3/2024</a:t>
+              <a:t>4/7/2026</a:t>
             </a:fld>
             <a:endParaRPr lang="en-US" altLang="en-US"/>
           </a:p>
@@ -6295,7 +6332,7 @@
             <a:fld id="{27290404-B4DF-40C6-BC44-F975D45F3652}" type="datetime1">
               <a:rPr lang="en-US" altLang="en-US"/>
               <a:pPr/>
-              <a:t>12/3/2024</a:t>
+              <a:t>4/7/2026</a:t>
             </a:fld>
             <a:endParaRPr lang="en-US" altLang="en-US"/>
           </a:p>
@@ -6501,7 +6538,7 @@
             <a:fld id="{719C60F9-E9A0-4E94-B5FA-11FE3BFD834F}" type="datetime1">
               <a:rPr lang="en-US" altLang="en-US"/>
               <a:pPr/>
-              <a:t>12/3/2024</a:t>
+              <a:t>4/7/2026</a:t>
             </a:fld>
             <a:endParaRPr lang="en-US" altLang="en-US"/>
           </a:p>
@@ -6868,7 +6905,7 @@
             <a:fld id="{124285A3-C37C-49F6-9502-FE6FBE380AB5}" type="datetime1">
               <a:rPr lang="en-US" altLang="en-US"/>
               <a:pPr/>
-              <a:t>12/3/2024</a:t>
+              <a:t>4/7/2026</a:t>
             </a:fld>
             <a:endParaRPr lang="en-US" altLang="en-US"/>
           </a:p>
@@ -7081,7 +7118,7 @@
             <a:fld id="{5664618A-4497-40BA-840C-643D9404D01A}" type="datetime1">
               <a:rPr lang="en-US" altLang="en-US"/>
               <a:pPr/>
-              <a:t>12/3/2024</a:t>
+              <a:t>4/7/2026</a:t>
             </a:fld>
             <a:endParaRPr lang="en-US" altLang="en-US"/>
           </a:p>
@@ -7295,7 +7332,7 @@
             <a:fld id="{7F204474-FE4F-4EC5-8598-1F33B22D8CAE}" type="datetime1">
               <a:rPr lang="en-US" altLang="en-US"/>
               <a:pPr/>
-              <a:t>12/3/2024</a:t>
+              <a:t>4/7/2026</a:t>
             </a:fld>
             <a:endParaRPr lang="en-US" altLang="en-US"/>
           </a:p>
@@ -7509,7 +7546,7 @@
             <a:fld id="{898A632C-3411-4773-807C-F25A21C96E07}" type="datetime1">
               <a:rPr lang="en-US" altLang="en-US"/>
               <a:pPr/>
-              <a:t>12/3/2024</a:t>
+              <a:t>4/7/2026</a:t>
             </a:fld>
             <a:endParaRPr lang="en-US" altLang="en-US"/>
           </a:p>
@@ -7749,7 +7786,7 @@
             <a:fld id="{31F42ACC-04CE-4688-85CF-7DCA9BC02C80}" type="datetime1">
               <a:rPr lang="en-US" altLang="en-US"/>
               <a:pPr/>
-              <a:t>12/3/2024</a:t>
+              <a:t>4/7/2026</a:t>
             </a:fld>
             <a:endParaRPr lang="en-US" altLang="en-US"/>
           </a:p>
@@ -8064,7 +8101,7 @@
             <a:fld id="{B62C2B18-D8B0-4327-AAD6-763896B9AB90}" type="datetime1">
               <a:rPr lang="en-US" altLang="en-US"/>
               <a:pPr/>
-              <a:t>12/3/2024</a:t>
+              <a:t>4/7/2026</a:t>
             </a:fld>
             <a:endParaRPr lang="en-US" altLang="en-US"/>
           </a:p>
@@ -8391,7 +8428,7 @@
             <a:fld id="{7EF3C794-C5DF-4436-8782-C7B846B06FAE}" type="datetime1">
               <a:rPr lang="en-US" altLang="en-US"/>
               <a:pPr/>
-              <a:t>12/3/2024</a:t>
+              <a:t>4/7/2026</a:t>
             </a:fld>
             <a:endParaRPr lang="en-US" altLang="en-US"/>
           </a:p>
@@ -8617,7 +8654,7 @@
             <a:fld id="{A5F37007-08C2-4AFE-89A8-33328AF01C45}" type="datetime1">
               <a:rPr lang="en-US" altLang="en-US"/>
               <a:pPr/>
-              <a:t>12/3/2024</a:t>
+              <a:t>4/7/2026</a:t>
             </a:fld>
             <a:endParaRPr lang="en-US" altLang="en-US"/>
           </a:p>
@@ -8843,7 +8880,7 @@
             <a:fld id="{CDE7BFBB-67D8-487C-8BAB-AF09902A7461}" type="datetime1">
               <a:rPr lang="en-US" altLang="en-US"/>
               <a:pPr/>
-              <a:t>12/3/2024</a:t>
+              <a:t>4/7/2026</a:t>
             </a:fld>
             <a:endParaRPr lang="en-US" altLang="en-US"/>
           </a:p>
@@ -9006,7 +9043,7 @@
             <a:fld id="{EFEE55C9-48EA-44AC-BB42-A930FAB67FF7}" type="datetime1">
               <a:rPr lang="en-US" altLang="en-US"/>
               <a:pPr/>
-              <a:t>12/3/2024</a:t>
+              <a:t>4/7/2026</a:t>
             </a:fld>
             <a:endParaRPr lang="en-US" altLang="en-US"/>
           </a:p>
@@ -9232,7 +9269,7 @@
             <a:fld id="{95AD568F-B972-4F67-85AF-04AD77F18632}" type="datetime1">
               <a:rPr lang="en-US" altLang="en-US"/>
               <a:pPr/>
-              <a:t>12/3/2024</a:t>
+              <a:t>4/7/2026</a:t>
             </a:fld>
             <a:endParaRPr lang="en-US" altLang="en-US"/>
           </a:p>
@@ -9458,7 +9495,7 @@
             <a:fld id="{64164768-FE20-41BD-ABA5-598D55BAC4E8}" type="datetime1">
               <a:rPr lang="en-US" altLang="en-US"/>
               <a:pPr/>
-              <a:t>12/3/2024</a:t>
+              <a:t>4/7/2026</a:t>
             </a:fld>
             <a:endParaRPr lang="en-US" altLang="en-US"/>
           </a:p>
@@ -9684,7 +9721,7 @@
             <a:fld id="{DB353C4F-B573-4355-ADE8-B26D7B211FAE}" type="datetime1">
               <a:rPr lang="en-US" altLang="en-US"/>
               <a:pPr/>
-              <a:t>12/3/2024</a:t>
+              <a:t>4/7/2026</a:t>
             </a:fld>
             <a:endParaRPr lang="en-US" altLang="en-US"/>
           </a:p>
@@ -9910,7 +9947,7 @@
             <a:fld id="{9D5E5186-04E8-4985-8F89-3D0E4855441B}" type="datetime1">
               <a:rPr lang="en-US" altLang="en-US"/>
               <a:pPr/>
-              <a:t>12/3/2024</a:t>
+              <a:t>4/7/2026</a:t>
             </a:fld>
             <a:endParaRPr lang="en-US" altLang="en-US"/>
           </a:p>
@@ -10144,7 +10181,7 @@
             <a:fld id="{2E39DA36-FA9A-41F6-8987-1359E9BD18F3}" type="datetime1">
               <a:rPr lang="en-US" altLang="en-US"/>
               <a:pPr/>
-              <a:t>12/3/2024</a:t>
+              <a:t>4/7/2026</a:t>
             </a:fld>
             <a:endParaRPr lang="en-US" altLang="en-US"/>
           </a:p>
@@ -10274,7 +10311,7 @@
                   <p:embed/>
                   <p:pic>
                     <p:nvPicPr>
-                      <p:cNvPr id="0" name="Object 8"/>
+                      <p:cNvPr id="205832" name="Object 8"/>
                       <p:cNvPicPr>
                         <a:picLocks noChangeAspect="1" noChangeArrowheads="1"/>
                       </p:cNvPicPr>
@@ -10360,7 +10397,7 @@
             <a:fld id="{6F39FBB0-CC1F-4EBF-8128-E84FABC6BCB8}" type="datetime1">
               <a:rPr lang="en-US" altLang="en-US"/>
               <a:pPr/>
-              <a:t>12/3/2024</a:t>
+              <a:t>4/7/2026</a:t>
             </a:fld>
             <a:endParaRPr lang="en-US" altLang="en-US"/>
           </a:p>
@@ -10473,13 +10510,13 @@
             <p:ph sz="quarter" idx="1"/>
             <p:extLst>
               <p:ext uri="{D42A27DB-BD31-4B8C-83A1-F6EECF244321}">
-                <p14:modId xmlns:p14="http://schemas.microsoft.com/office/powerpoint/2010/main" val="1887030783"/>
+                <p14:modId xmlns:p14="http://schemas.microsoft.com/office/powerpoint/2010/main" val="3578318584"/>
               </p:ext>
             </p:extLst>
           </p:nvPr>
         </p:nvGraphicFramePr>
         <p:xfrm>
-          <a:off x="1298448" y="381000"/>
+          <a:off x="1327810" y="266700"/>
           <a:ext cx="6172200" cy="6172200"/>
         </p:xfrm>
         <a:graphic>
@@ -10495,7 +10532,7 @@
                   <p:embed/>
                   <p:pic>
                     <p:nvPicPr>
-                      <p:cNvPr id="0" name="Object 10"/>
+                      <p:cNvPr id="213002" name="Object 10"/>
                       <p:cNvPicPr>
                         <a:picLocks noChangeAspect="1" noChangeArrowheads="1"/>
                       </p:cNvPicPr>
@@ -10516,7 +10553,7 @@
                     </p:blipFill>
                     <p:spPr bwMode="auto">
                       <a:xfrm>
-                        <a:off x="1298448" y="381000"/>
+                        <a:off x="1327810" y="266700"/>
                         <a:ext cx="6172200" cy="6172200"/>
                       </a:xfrm>
                       <a:prstGeom prst="rect">
@@ -10614,7 +10651,7 @@
             <a:fld id="{5AE3DD3E-CD5B-4AE3-A197-85F8191312C3}" type="datetime1">
               <a:rPr lang="en-US" altLang="en-US"/>
               <a:pPr/>
-              <a:t>12/3/2024</a:t>
+              <a:t>4/7/2026</a:t>
             </a:fld>
             <a:endParaRPr lang="en-US" altLang="en-US"/>
           </a:p>
@@ -10800,7 +10837,7 @@
             <a:fld id="{35FC0B1C-157C-4459-9BE3-E39188D7EACD}" type="datetime1">
               <a:rPr lang="en-US" altLang="en-US"/>
               <a:pPr/>
-              <a:t>12/3/2024</a:t>
+              <a:t>4/7/2026</a:t>
             </a:fld>
             <a:endParaRPr lang="en-US" altLang="en-US"/>
           </a:p>
@@ -11014,7 +11051,7 @@
             <a:fld id="{98A19279-2967-450F-BDAD-47B5810551B9}" type="datetime1">
               <a:rPr lang="en-US" altLang="en-US"/>
               <a:pPr/>
-              <a:t>12/3/2024</a:t>
+              <a:t>4/7/2026</a:t>
             </a:fld>
             <a:endParaRPr lang="en-US" altLang="en-US"/>
           </a:p>
@@ -11200,7 +11237,7 @@
             <a:fld id="{33AB958A-789E-40C0-8B26-51D4E1BD65A6}" type="datetime1">
               <a:rPr lang="en-US" altLang="en-US"/>
               <a:pPr/>
-              <a:t>12/3/2024</a:t>
+              <a:t>4/7/2026</a:t>
             </a:fld>
             <a:endParaRPr lang="en-US" altLang="en-US"/>
           </a:p>
@@ -11406,7 +11443,7 @@
             <a:fld id="{4DD586B8-BE97-400C-A0C1-DCB36840D631}" type="datetime1">
               <a:rPr lang="en-US" altLang="en-US"/>
               <a:pPr/>
-              <a:t>12/3/2024</a:t>
+              <a:t>4/7/2026</a:t>
             </a:fld>
             <a:endParaRPr lang="en-US" altLang="en-US"/>
           </a:p>
@@ -12892,17 +12929,6 @@
 </file>
 
 <file path=customXml/item1.xml><?xml version="1.0" encoding="utf-8"?>
-<p:properties xmlns:p="http://schemas.microsoft.com/office/2006/metadata/properties" xmlns:xsi="http://www.w3.org/2001/XMLSchema-instance" xmlns:pc="http://schemas.microsoft.com/office/infopath/2007/PartnerControls">
-  <documentManagement>
-    <TaxCatchAll xmlns="2ae7472c-b71f-4cab-b94a-416f482a757b" xsi:nil="true"/>
-    <lcf76f155ced4ddcb4097134ff3c332f xmlns="41b3182d-22ee-41df-9219-a7264fbbfb0e">
-      <Terms xmlns="http://schemas.microsoft.com/office/infopath/2007/PartnerControls"/>
-    </lcf76f155ced4ddcb4097134ff3c332f>
-  </documentManagement>
-</p:properties>
-</file>
-
-<file path=customXml/item2.xml><?xml version="1.0" encoding="utf-8"?>
 <ct:contentTypeSchema xmlns:ct="http://schemas.microsoft.com/office/2006/metadata/contentType" xmlns:ma="http://schemas.microsoft.com/office/2006/metadata/properties/metaAttributes" ct:_="" ma:_="" ma:contentTypeName="Document" ma:contentTypeID="0x010100162E8B9B8F494F4F9FA5AC6115F8BAFC" ma:contentTypeVersion="14" ma:contentTypeDescription="Create a new document." ma:contentTypeScope="" ma:versionID="3d2c6979e8007f0c673cdef31668f95a">
   <xsd:schema xmlns:xsd="http://www.w3.org/2001/XMLSchema" xmlns:xs="http://www.w3.org/2001/XMLSchema" xmlns:p="http://schemas.microsoft.com/office/2006/metadata/properties" xmlns:ns2="41b3182d-22ee-41df-9219-a7264fbbfb0e" xmlns:ns3="2ae7472c-b71f-4cab-b94a-416f482a757b" targetNamespace="http://schemas.microsoft.com/office/2006/metadata/properties" ma:root="true" ma:fieldsID="f3c0934017ae9f5ce032209485dc8b02" ns2:_="" ns3:_="">
     <xsd:import namespace="41b3182d-22ee-41df-9219-a7264fbbfb0e"/>
@@ -13131,6 +13157,17 @@
 </ct:contentTypeSchema>
 </file>
 
+<file path=customXml/item2.xml><?xml version="1.0" encoding="utf-8"?>
+<p:properties xmlns:p="http://schemas.microsoft.com/office/2006/metadata/properties" xmlns:xsi="http://www.w3.org/2001/XMLSchema-instance" xmlns:pc="http://schemas.microsoft.com/office/infopath/2007/PartnerControls">
+  <documentManagement>
+    <TaxCatchAll xmlns="2ae7472c-b71f-4cab-b94a-416f482a757b" xsi:nil="true"/>
+    <lcf76f155ced4ddcb4097134ff3c332f xmlns="41b3182d-22ee-41df-9219-a7264fbbfb0e">
+      <Terms xmlns="http://schemas.microsoft.com/office/infopath/2007/PartnerControls"/>
+    </lcf76f155ced4ddcb4097134ff3c332f>
+  </documentManagement>
+</p:properties>
+</file>
+
 <file path=customXml/item3.xml><?xml version="1.0" encoding="utf-8"?>
 <?mso-contentType ?>
 <FormTemplates xmlns="http://schemas.microsoft.com/sharepoint/v3/contenttype/forms">
@@ -13141,17 +13178,6 @@
 </file>
 
 <file path=customXml/itemProps1.xml><?xml version="1.0" encoding="utf-8"?>
-<ds:datastoreItem xmlns:ds="http://schemas.openxmlformats.org/officeDocument/2006/customXml" ds:itemID="{E5B4DE0A-17D0-4437-9236-83AAAC1D6045}">
-  <ds:schemaRefs>
-    <ds:schemaRef ds:uri="2ae7472c-b71f-4cab-b94a-416f482a757b"/>
-    <ds:schemaRef ds:uri="41b3182d-22ee-41df-9219-a7264fbbfb0e"/>
-    <ds:schemaRef ds:uri="http://schemas.microsoft.com/office/2006/metadata/properties"/>
-    <ds:schemaRef ds:uri="http://schemas.microsoft.com/office/infopath/2007/PartnerControls"/>
-  </ds:schemaRefs>
-</ds:datastoreItem>
-</file>
-
-<file path=customXml/itemProps2.xml><?xml version="1.0" encoding="utf-8"?>
 <ds:datastoreItem xmlns:ds="http://schemas.openxmlformats.org/officeDocument/2006/customXml" ds:itemID="{59487A70-8453-4D65-9995-21113B54F52C}">
   <ds:schemaRefs>
     <ds:schemaRef ds:uri="2ae7472c-b71f-4cab-b94a-416f482a757b"/>
@@ -13170,6 +13196,17 @@
 </ds:datastoreItem>
 </file>
 
+<file path=customXml/itemProps2.xml><?xml version="1.0" encoding="utf-8"?>
+<ds:datastoreItem xmlns:ds="http://schemas.openxmlformats.org/officeDocument/2006/customXml" ds:itemID="{E5B4DE0A-17D0-4437-9236-83AAAC1D6045}">
+  <ds:schemaRefs>
+    <ds:schemaRef ds:uri="2ae7472c-b71f-4cab-b94a-416f482a757b"/>
+    <ds:schemaRef ds:uri="41b3182d-22ee-41df-9219-a7264fbbfb0e"/>
+    <ds:schemaRef ds:uri="http://schemas.microsoft.com/office/2006/metadata/properties"/>
+    <ds:schemaRef ds:uri="http://schemas.microsoft.com/office/infopath/2007/PartnerControls"/>
+  </ds:schemaRefs>
+</ds:datastoreItem>
+</file>
+
 <file path=customXml/itemProps3.xml><?xml version="1.0" encoding="utf-8"?>
 <ds:datastoreItem xmlns:ds="http://schemas.openxmlformats.org/officeDocument/2006/customXml" ds:itemID="{4554799B-7C9E-49B2-8741-E8F141C03E15}">
   <ds:schemaRefs>

</xml_diff>